<commit_message>
chore(examples): align trio outputs and fix textbox schema usage
- Rename every script's output to match its name-aligned trio
  (formulas.sh→formulas.docx, charts.sh→charts.xlsx, etc.) and
  use $(dirname "$0") so outputs always land next to the script
  regardless of caller CWD.
- tables.sh produces a 3-format demo so its xlsx/pptx are renamed to
  tables.{xlsx,pptx} alongside tables.docx.
- 3d-model.sh: fix nonexistent outputs/ subpath.
- textbox.sh: append paragraphs via "//w:body/w:sectPr"+insertbefore
  instead of "//w:body"+append, since w:sectPr must be the last
  child of w:body. Final document now validates clean.
- Add missing numbering-showcase.md stub to complete the trio.
- Refresh README.md to match real script names and current help-command
  syntax (officecli help <fmt> ...).
</commit_message>
<xml_diff>
--- a/examples/ppt/presentation.pptx
+++ b/examples/ppt/presentation.pptx
@@ -5,12 +5,12 @@
     <p:sldMasterId xmlns:r="http://schemas.openxmlformats.org/officeDocument/2006/relationships" id="2147483648" r:id="rId1"/>
   </p:sldMasterIdLst>
   <p:sldIdLst>
-    <p:sldId id="256" r:id="Rd34af005f00544c3"/>
-    <p:sldId id="257" r:id="R0d30e50edf414cf6"/>
-    <p:sldId id="258" r:id="R6d82aa3e7c1340e2"/>
-    <p:sldId id="259" r:id="Rd0796935c7ba4ff4"/>
-    <p:sldId id="260" r:id="R8613234441414bf7"/>
-    <p:sldId id="261" r:id="R42f4b4d6c2ce4ab2"/>
+    <p:sldId id="256" r:id="R604da48190434747"/>
+    <p:sldId id="257" r:id="R12336ed84168439c"/>
+    <p:sldId id="258" r:id="Re626b684d7754d36"/>
+    <p:sldId id="259" r:id="R64b52d03b7b84dda"/>
+    <p:sldId id="260" r:id="Rd0cc7538101045f5"/>
+    <p:sldId id="261" r:id="Reb81dd2cdbe94d5f"/>
   </p:sldIdLst>
   <p:sldSz cx="12192000" cy="6858000"/>
   <p:notesSz cx="6858000" cy="9144000"/>
@@ -19,7 +19,7 @@
 
 <file path=ppt/slideLayouts/slideLayout1.xml><?xml version="1.0" encoding="utf-8"?>
 <p:sldLayout xmlns:p="http://schemas.openxmlformats.org/presentationml/2006/main" type="blank">
-  <p:cSld>
+  <p:cSld name="Blank">
     <p:spTree>
       <p:nvGrpSpPr>
         <p:cNvPr id="1" name=""/>
@@ -27,6 +27,258 @@
         <p:nvPr/>
       </p:nvGrpSpPr>
       <p:grpSpPr/>
+    </p:spTree>
+  </p:cSld>
+</p:sldLayout>
+</file>
+
+<file path=ppt/slideLayouts/slideLayout2.xml><?xml version="1.0" encoding="utf-8"?>
+<p:sldLayout xmlns:p="http://schemas.openxmlformats.org/presentationml/2006/main" type="title">
+  <p:cSld name="Title Slide">
+    <p:spTree>
+      <p:nvGrpSpPr>
+        <p:cNvPr id="1" name=""/>
+        <p:cNvGrpSpPr/>
+        <p:nvPr/>
+      </p:nvGrpSpPr>
+      <p:grpSpPr/>
+      <p:sp>
+        <p:nvSpPr>
+          <p:cNvPr id="2" name="Title"/>
+          <p:cNvSpPr>
+            <a:spLocks xmlns:a="http://schemas.openxmlformats.org/drawingml/2006/main" noGrp="1"/>
+          </p:cNvSpPr>
+          <p:nvPr>
+            <p:ph type="ctrTitle"/>
+          </p:nvPr>
+        </p:nvSpPr>
+        <p:spPr>
+          <a:xfrm xmlns:a="http://schemas.openxmlformats.org/drawingml/2006/main">
+            <a:off x="685800" y="2130425"/>
+            <a:ext cx="7772400" cy="1470025"/>
+          </a:xfrm>
+        </p:spPr>
+        <p:txBody>
+          <a:bodyPr xmlns:a="http://schemas.openxmlformats.org/drawingml/2006/main"/>
+          <a:lstStyle xmlns:a="http://schemas.openxmlformats.org/drawingml/2006/main"/>
+          <a:p xmlns:a="http://schemas.openxmlformats.org/drawingml/2006/main">
+            <a:endParaRPr lang="en-US"/>
+          </a:p>
+        </p:txBody>
+      </p:sp>
+      <p:sp>
+        <p:nvSpPr>
+          <p:cNvPr id="3" name="Subtitle"/>
+          <p:cNvSpPr>
+            <a:spLocks xmlns:a="http://schemas.openxmlformats.org/drawingml/2006/main" noGrp="1"/>
+          </p:cNvSpPr>
+          <p:nvPr>
+            <p:ph type="subTitle"/>
+          </p:nvPr>
+        </p:nvSpPr>
+        <p:spPr>
+          <a:xfrm xmlns:a="http://schemas.openxmlformats.org/drawingml/2006/main">
+            <a:off x="1371600" y="3886200"/>
+            <a:ext cx="6400800" cy="1752600"/>
+          </a:xfrm>
+        </p:spPr>
+        <p:txBody>
+          <a:bodyPr xmlns:a="http://schemas.openxmlformats.org/drawingml/2006/main"/>
+          <a:lstStyle xmlns:a="http://schemas.openxmlformats.org/drawingml/2006/main"/>
+          <a:p xmlns:a="http://schemas.openxmlformats.org/drawingml/2006/main">
+            <a:endParaRPr lang="en-US"/>
+          </a:p>
+        </p:txBody>
+      </p:sp>
+    </p:spTree>
+  </p:cSld>
+</p:sldLayout>
+</file>
+
+<file path=ppt/slideLayouts/slideLayout3.xml><?xml version="1.0" encoding="utf-8"?>
+<p:sldLayout xmlns:p="http://schemas.openxmlformats.org/presentationml/2006/main" type="objTx">
+  <p:cSld name="Title and Content">
+    <p:spTree>
+      <p:nvGrpSpPr>
+        <p:cNvPr id="1" name=""/>
+        <p:cNvGrpSpPr/>
+        <p:nvPr/>
+      </p:nvGrpSpPr>
+      <p:grpSpPr/>
+      <p:sp>
+        <p:nvSpPr>
+          <p:cNvPr id="2" name="Title"/>
+          <p:cNvSpPr>
+            <a:spLocks xmlns:a="http://schemas.openxmlformats.org/drawingml/2006/main" noGrp="1"/>
+          </p:cNvSpPr>
+          <p:nvPr>
+            <p:ph type="title"/>
+          </p:nvPr>
+        </p:nvSpPr>
+        <p:spPr>
+          <a:xfrm xmlns:a="http://schemas.openxmlformats.org/drawingml/2006/main">
+            <a:off x="838200" y="365125"/>
+            <a:ext cx="10515600" cy="1325563"/>
+          </a:xfrm>
+        </p:spPr>
+        <p:txBody>
+          <a:bodyPr xmlns:a="http://schemas.openxmlformats.org/drawingml/2006/main"/>
+          <a:lstStyle xmlns:a="http://schemas.openxmlformats.org/drawingml/2006/main"/>
+          <a:p xmlns:a="http://schemas.openxmlformats.org/drawingml/2006/main">
+            <a:endParaRPr lang="en-US"/>
+          </a:p>
+        </p:txBody>
+      </p:sp>
+      <p:sp>
+        <p:nvSpPr>
+          <p:cNvPr id="3" name="Content"/>
+          <p:cNvSpPr>
+            <a:spLocks xmlns:a="http://schemas.openxmlformats.org/drawingml/2006/main" noGrp="1"/>
+          </p:cNvSpPr>
+          <p:nvPr>
+            <p:ph type="body"/>
+          </p:nvPr>
+        </p:nvSpPr>
+        <p:spPr>
+          <a:xfrm xmlns:a="http://schemas.openxmlformats.org/drawingml/2006/main">
+            <a:off x="838200" y="1825625"/>
+            <a:ext cx="10515600" cy="4351338"/>
+          </a:xfrm>
+        </p:spPr>
+        <p:txBody>
+          <a:bodyPr xmlns:a="http://schemas.openxmlformats.org/drawingml/2006/main"/>
+          <a:lstStyle xmlns:a="http://schemas.openxmlformats.org/drawingml/2006/main"/>
+          <a:p xmlns:a="http://schemas.openxmlformats.org/drawingml/2006/main">
+            <a:endParaRPr lang="en-US"/>
+          </a:p>
+        </p:txBody>
+      </p:sp>
+    </p:spTree>
+  </p:cSld>
+</p:sldLayout>
+</file>
+
+<file path=ppt/slideLayouts/slideLayout4.xml><?xml version="1.0" encoding="utf-8"?>
+<p:sldLayout xmlns:p="http://schemas.openxmlformats.org/presentationml/2006/main" type="twoColTx">
+  <p:cSld name="Two Content">
+    <p:spTree>
+      <p:nvGrpSpPr>
+        <p:cNvPr id="1" name=""/>
+        <p:cNvGrpSpPr/>
+        <p:nvPr/>
+      </p:nvGrpSpPr>
+      <p:grpSpPr/>
+      <p:sp>
+        <p:nvSpPr>
+          <p:cNvPr id="2" name="Title"/>
+          <p:cNvSpPr>
+            <a:spLocks xmlns:a="http://schemas.openxmlformats.org/drawingml/2006/main" noGrp="1"/>
+          </p:cNvSpPr>
+          <p:nvPr>
+            <p:ph type="title"/>
+          </p:nvPr>
+        </p:nvSpPr>
+        <p:spPr>
+          <a:xfrm xmlns:a="http://schemas.openxmlformats.org/drawingml/2006/main">
+            <a:off x="838200" y="365125"/>
+            <a:ext cx="10515600" cy="1325563"/>
+          </a:xfrm>
+        </p:spPr>
+        <p:txBody>
+          <a:bodyPr xmlns:a="http://schemas.openxmlformats.org/drawingml/2006/main"/>
+          <a:lstStyle xmlns:a="http://schemas.openxmlformats.org/drawingml/2006/main"/>
+          <a:p xmlns:a="http://schemas.openxmlformats.org/drawingml/2006/main">
+            <a:endParaRPr lang="en-US"/>
+          </a:p>
+        </p:txBody>
+      </p:sp>
+      <p:sp>
+        <p:nvSpPr>
+          <p:cNvPr id="3" name="Content Left"/>
+          <p:cNvSpPr>
+            <a:spLocks xmlns:a="http://schemas.openxmlformats.org/drawingml/2006/main" noGrp="1"/>
+          </p:cNvSpPr>
+          <p:nvPr>
+            <p:ph type="body"/>
+          </p:nvPr>
+        </p:nvSpPr>
+        <p:spPr>
+          <a:xfrm xmlns:a="http://schemas.openxmlformats.org/drawingml/2006/main">
+            <a:off x="838200" y="1825625"/>
+            <a:ext cx="5181600" cy="4351338"/>
+          </a:xfrm>
+        </p:spPr>
+        <p:txBody>
+          <a:bodyPr xmlns:a="http://schemas.openxmlformats.org/drawingml/2006/main"/>
+          <a:lstStyle xmlns:a="http://schemas.openxmlformats.org/drawingml/2006/main"/>
+          <a:p xmlns:a="http://schemas.openxmlformats.org/drawingml/2006/main">
+            <a:endParaRPr lang="en-US"/>
+          </a:p>
+        </p:txBody>
+      </p:sp>
+      <p:sp>
+        <p:nvSpPr>
+          <p:cNvPr id="4" name="Content Right"/>
+          <p:cNvSpPr>
+            <a:spLocks xmlns:a="http://schemas.openxmlformats.org/drawingml/2006/main" noGrp="1"/>
+          </p:cNvSpPr>
+          <p:nvPr>
+            <p:ph type="body"/>
+          </p:nvPr>
+        </p:nvSpPr>
+        <p:spPr>
+          <a:xfrm xmlns:a="http://schemas.openxmlformats.org/drawingml/2006/main">
+            <a:off x="6172200" y="1825625"/>
+            <a:ext cx="5181600" cy="4351338"/>
+          </a:xfrm>
+        </p:spPr>
+        <p:txBody>
+          <a:bodyPr xmlns:a="http://schemas.openxmlformats.org/drawingml/2006/main"/>
+          <a:lstStyle xmlns:a="http://schemas.openxmlformats.org/drawingml/2006/main"/>
+          <a:p xmlns:a="http://schemas.openxmlformats.org/drawingml/2006/main">
+            <a:endParaRPr lang="en-US"/>
+          </a:p>
+        </p:txBody>
+      </p:sp>
+    </p:spTree>
+  </p:cSld>
+</p:sldLayout>
+</file>
+
+<file path=ppt/slideLayouts/slideLayout5.xml><?xml version="1.0" encoding="utf-8"?>
+<p:sldLayout xmlns:p="http://schemas.openxmlformats.org/presentationml/2006/main" type="titleOnly">
+  <p:cSld name="Title Only">
+    <p:spTree>
+      <p:nvGrpSpPr>
+        <p:cNvPr id="1" name=""/>
+        <p:cNvGrpSpPr/>
+        <p:nvPr/>
+      </p:nvGrpSpPr>
+      <p:grpSpPr/>
+      <p:sp>
+        <p:nvSpPr>
+          <p:cNvPr id="2" name="Title"/>
+          <p:cNvSpPr>
+            <a:spLocks xmlns:a="http://schemas.openxmlformats.org/drawingml/2006/main" noGrp="1"/>
+          </p:cNvSpPr>
+          <p:nvPr>
+            <p:ph type="title"/>
+          </p:nvPr>
+        </p:nvSpPr>
+        <p:spPr>
+          <a:xfrm xmlns:a="http://schemas.openxmlformats.org/drawingml/2006/main">
+            <a:off x="838200" y="365125"/>
+            <a:ext cx="10515600" cy="1325563"/>
+          </a:xfrm>
+        </p:spPr>
+        <p:txBody>
+          <a:bodyPr xmlns:a="http://schemas.openxmlformats.org/drawingml/2006/main"/>
+          <a:lstStyle xmlns:a="http://schemas.openxmlformats.org/drawingml/2006/main"/>
+          <a:p xmlns:a="http://schemas.openxmlformats.org/drawingml/2006/main">
+            <a:endParaRPr lang="en-US"/>
+          </a:p>
+        </p:txBody>
+      </p:sp>
     </p:spTree>
   </p:cSld>
 </p:sldLayout>
@@ -47,12 +299,16 @@
   <p:clrMap bg1="lt1" tx1="dk1" bg2="lt2" tx2="dk2" accent1="accent1" accent2="accent2" accent3="accent3" accent4="accent4" accent5="accent5" accent6="accent6" hlink="hlink" folHlink="folHlink"/>
   <p:sldLayoutIdLst>
     <p:sldLayoutId xmlns:r="http://schemas.openxmlformats.org/officeDocument/2006/relationships" id="2147483649" r:id="rId1"/>
+    <p:sldLayoutId xmlns:r="http://schemas.openxmlformats.org/officeDocument/2006/relationships" id="2147483650" r:id="rId2"/>
+    <p:sldLayoutId xmlns:r="http://schemas.openxmlformats.org/officeDocument/2006/relationships" id="2147483651" r:id="rId3"/>
+    <p:sldLayoutId xmlns:r="http://schemas.openxmlformats.org/officeDocument/2006/relationships" id="2147483652" r:id="rId4"/>
+    <p:sldLayoutId xmlns:r="http://schemas.openxmlformats.org/officeDocument/2006/relationships" id="2147483653" r:id="rId5"/>
   </p:sldLayoutIdLst>
 </p:sldMaster>
 </file>
 
 <file path=ppt/slides/slide1.xml><?xml version="1.0" encoding="utf-8"?>
-<p:sld xmlns:p="http://schemas.openxmlformats.org/presentationml/2006/main">
+<p:sld xmlns:a="http://schemas.openxmlformats.org/drawingml/2006/main" xmlns:p="http://schemas.openxmlformats.org/presentationml/2006/main">
   <p:cSld xmlns:p="http://schemas.openxmlformats.org/presentationml/2006/main">
     <p:bg>
       <p:bgPr>
@@ -297,7 +553,7 @@
 </file>
 
 <file path=ppt/slides/slide2.xml><?xml version="1.0" encoding="utf-8"?>
-<p:sld xmlns:p="http://schemas.openxmlformats.org/presentationml/2006/main">
+<p:sld xmlns:a="http://schemas.openxmlformats.org/drawingml/2006/main" xmlns:p="http://schemas.openxmlformats.org/presentationml/2006/main">
   <p:cSld xmlns:p="http://schemas.openxmlformats.org/presentationml/2006/main">
     <p:bg>
       <p:bgPr>
@@ -611,7 +867,7 @@
 </file>
 
 <file path=ppt/slides/slide3.xml><?xml version="1.0" encoding="utf-8"?>
-<p:sld xmlns:p="http://schemas.openxmlformats.org/presentationml/2006/main">
+<p:sld xmlns:a="http://schemas.openxmlformats.org/drawingml/2006/main" xmlns:p="http://schemas.openxmlformats.org/presentationml/2006/main">
   <p:cSld xmlns:p="http://schemas.openxmlformats.org/presentationml/2006/main">
     <p:bg>
       <p:bgPr>
@@ -949,7 +1205,7 @@
 </file>
 
 <file path=ppt/slides/slide4.xml><?xml version="1.0" encoding="utf-8"?>
-<p:sld xmlns:p="http://schemas.openxmlformats.org/presentationml/2006/main">
+<p:sld xmlns:a="http://schemas.openxmlformats.org/drawingml/2006/main" xmlns:p="http://schemas.openxmlformats.org/presentationml/2006/main">
   <p:cSld xmlns:p="http://schemas.openxmlformats.org/presentationml/2006/main">
     <p:bg>
       <p:bgPr>
@@ -1148,7 +1404,7 @@
 </file>
 
 <file path=ppt/slides/slide5.xml><?xml version="1.0" encoding="utf-8"?>
-<p:sld xmlns:p="http://schemas.openxmlformats.org/presentationml/2006/main">
+<p:sld xmlns:a="http://schemas.openxmlformats.org/drawingml/2006/main" xmlns:p="http://schemas.openxmlformats.org/presentationml/2006/main">
   <p:cSld xmlns:p="http://schemas.openxmlformats.org/presentationml/2006/main">
     <p:bg>
       <p:bgPr>
@@ -1593,7 +1849,7 @@
 </file>
 
 <file path=ppt/slides/slide6.xml><?xml version="1.0" encoding="utf-8"?>
-<p:sld xmlns:p="http://schemas.openxmlformats.org/presentationml/2006/main">
+<p:sld xmlns:a="http://schemas.openxmlformats.org/drawingml/2006/main" xmlns:p="http://schemas.openxmlformats.org/presentationml/2006/main">
   <p:cSld xmlns:p="http://schemas.openxmlformats.org/presentationml/2006/main">
     <p:bg>
       <p:bgPr>

</xml_diff>